<commit_message>
docs(read-coherence): extend deck to 13 slides + thesis one-pager + figures
- figures: add fig6 (alt-splicing = distinct junction chains), fig7 (PSV bridge),
  fig8 (calling a PSV), fig9 (thesis-contribution matrix); fix fig5 results y-axis
  to "StringTie-missed isoforms recovered" and fig4 legibility.
- deck: 8 -> 13 slides (+ pseudocode, not-clustering rigor, alt-splice, prior-art,
  calling-a-PSV, using-PSVs, contribution finale) with speaker notes; PDF + PPTX.
- THESIS_CONTRIBUTION.{md,pdf} + render_onepager.py: the formal copy-resolved-isoform
  problem on a spliced family variation graph + identifiability theorem + positioning.

Co-Authored-By: Claude Opus 4.8 <noreply@anthropic.com>
</commit_message>
<xml_diff>
--- a/bench/readcoherence_fig/slides/read_coherence_deck.pptx
+++ b/bench/readcoherence_fig/slides/read_coherence_deck.pptx
@@ -12,6 +12,12 @@
     <p:sldId id="260" r:id="rId12"/>
     <p:sldId id="261" r:id="rId13"/>
     <p:sldId id="262" r:id="rId14"/>
+    <p:sldId id="263" r:id="rId15"/>
+    <p:sldId id="264" r:id="rId16"/>
+    <p:sldId id="265" r:id="rId17"/>
+    <p:sldId id="266" r:id="rId18"/>
+    <p:sldId id="267" r:id="rId19"/>
+    <p:sldId id="268" r:id="rId20"/>
   </p:sldIdLst>
   <p:sldSz cx="12191695" cy="6858000" type="screen4x3"/>
   <p:notesSz cx="6858000" cy="9144000"/>
@@ -533,6 +539,216 @@
 </p:notes>
 </file>
 
+<file path=ppt/notesSlides/notesSlide10.xml><?xml version="1.0" encoding="utf-8"?>
+<p:notes xmlns:a="http://schemas.openxmlformats.org/drawingml/2006/main" xmlns:p="http://schemas.openxmlformats.org/presentationml/2006/main" xmlns:r="http://schemas.openxmlformats.org/officeDocument/2006/relationships">
+  <p:cSld>
+    <p:spTree>
+      <p:nvGrpSpPr>
+        <p:cNvPr id="1" name=""/>
+        <p:cNvGrpSpPr/>
+        <p:nvPr/>
+      </p:nvGrpSpPr>
+      <p:grpSpPr>
+        <a:xfrm>
+          <a:off x="0" y="0"/>
+          <a:ext cx="0" cy="0"/>
+          <a:chOff x="0" y="0"/>
+          <a:chExt cx="0" cy="0"/>
+        </a:xfrm>
+      </p:grpSpPr>
+      <p:sp>
+        <p:nvSpPr>
+          <p:cNvPr id="2" name="Slide Image Placeholder 1"/>
+          <p:cNvSpPr>
+            <a:spLocks noGrp="1"/>
+          </p:cNvSpPr>
+          <p:nvPr>
+            <p:ph type="sldImg" idx="2"/>
+          </p:nvPr>
+        </p:nvSpPr>
+        <p:spPr/>
+      </p:sp>
+      <p:sp>
+        <p:nvSpPr>
+          <p:cNvPr id="3" name="Notes Placeholder 2"/>
+          <p:cNvSpPr>
+            <a:spLocks noGrp="1"/>
+          </p:cNvSpPr>
+          <p:nvPr>
+            <p:ph type="body" idx="3" sz="quarter"/>
+          </p:nvPr>
+        </p:nvSpPr>
+        <p:spPr/>
+        <p:txBody>
+          <a:bodyPr/>
+          <a:lstStyle/>
+          <a:p>
+            <a:r>
+              <a:t>How a PSV is determined. Homologous columns come from aligning the copies with POA (partial-order alignment, the graph generalization of Needleman-Wunsch); a column where the copies carry fixed different bases is a candidate PSV. It is accepted as real (not sequencing error or within-copy SNP) when the allele is consistent across essentially all reads of a copy and co-segregates with other PSVs; a family is declared identifiable only with &gt;= K such columns, because K independent error-agreements are improbable at long-read error rates. Reads are then assigned to a copy by which PSV alleles they carry, plus the NM/AS gap.</a:t>
+            </a:r>
+          </a:p>
+        </p:txBody>
+      </p:sp>
+      <p:sp>
+        <p:nvSpPr>
+          <p:cNvPr id="4" name="Slide Number Placeholder 3"/>
+          <p:cNvSpPr>
+            <a:spLocks noGrp="1"/>
+          </p:cNvSpPr>
+          <p:nvPr>
+            <p:ph type="sldNum" idx="5" sz="quarter"/>
+          </p:nvPr>
+        </p:nvSpPr>
+        <p:spPr/>
+      </p:sp>
+    </p:spTree>
+  </p:cSld>
+  <p:clrMapOvr>
+    <a:masterClrMapping/>
+  </p:clrMapOvr>
+</p:notes>
+</file>
+
+<file path=ppt/notesSlides/notesSlide11.xml><?xml version="1.0" encoding="utf-8"?>
+<p:notes xmlns:a="http://schemas.openxmlformats.org/drawingml/2006/main" xmlns:p="http://schemas.openxmlformats.org/presentationml/2006/main" xmlns:r="http://schemas.openxmlformats.org/officeDocument/2006/relationships">
+  <p:cSld>
+    <p:spTree>
+      <p:nvGrpSpPr>
+        <p:cNvPr id="1" name=""/>
+        <p:cNvGrpSpPr/>
+        <p:nvPr/>
+      </p:nvGrpSpPr>
+      <p:grpSpPr>
+        <a:xfrm>
+          <a:off x="0" y="0"/>
+          <a:ext cx="0" cy="0"/>
+          <a:chOff x="0" y="0"/>
+          <a:chExt cx="0" cy="0"/>
+        </a:xfrm>
+      </p:grpSpPr>
+      <p:sp>
+        <p:nvSpPr>
+          <p:cNvPr id="2" name="Slide Image Placeholder 1"/>
+          <p:cNvSpPr>
+            <a:spLocks noGrp="1"/>
+          </p:cNvSpPr>
+          <p:nvPr>
+            <p:ph type="sldImg" idx="2"/>
+          </p:nvPr>
+        </p:nvSpPr>
+        <p:spPr/>
+      </p:sp>
+      <p:sp>
+        <p:nvSpPr>
+          <p:cNvPr id="3" name="Notes Placeholder 2"/>
+          <p:cNvSpPr>
+            <a:spLocks noGrp="1"/>
+          </p:cNvSpPr>
+          <p:nvPr>
+            <p:ph type="body" idx="3" sz="quarter"/>
+          </p:nvPr>
+        </p:nvSpPr>
+        <p:spPr/>
+        <p:txBody>
+          <a:bodyPr/>
+          <a:lstStyle/>
+          <a:p>
+            <a:r>
+              <a:t>This is the novel direction and answers 'how would you use PSVs here'. For near-identical paralog copies that share the SAME junction chain, read-coherence alone can't separate them — same key, one bucket. PSVs (paralog-sequence variants: bases that differ consistently between copies) add a second axis: among reads in that bucket, partition by their PSV-allele vector to recover the individual copies. The transcript key extends from (intron chain) to (intron chain + PSV-allele vector): junctions give the structural identity, PSVs give the copy identity, both read off the SAME molecule. Closest prior art stops short: FLAIR2 phases per-read isoforms by HAPLOTYPE (alleles of one gene), Paraphase does PSV-based paralog resolution at the DNA/gene level — neither does paralog-copy-resolved isoform assembly. Caveat: bounded by identifiability — copies separate only when reads span enough PSVs above the error floor.</a:t>
+            </a:r>
+          </a:p>
+        </p:txBody>
+      </p:sp>
+      <p:sp>
+        <p:nvSpPr>
+          <p:cNvPr id="4" name="Slide Number Placeholder 3"/>
+          <p:cNvSpPr>
+            <a:spLocks noGrp="1"/>
+          </p:cNvSpPr>
+          <p:nvPr>
+            <p:ph type="sldNum" idx="5" sz="quarter"/>
+          </p:nvPr>
+        </p:nvSpPr>
+        <p:spPr/>
+      </p:sp>
+    </p:spTree>
+  </p:cSld>
+  <p:clrMapOvr>
+    <a:masterClrMapping/>
+  </p:clrMapOvr>
+</p:notes>
+</file>
+
+<file path=ppt/notesSlides/notesSlide12.xml><?xml version="1.0" encoding="utf-8"?>
+<p:notes xmlns:a="http://schemas.openxmlformats.org/drawingml/2006/main" xmlns:p="http://schemas.openxmlformats.org/presentationml/2006/main" xmlns:r="http://schemas.openxmlformats.org/officeDocument/2006/relationships">
+  <p:cSld>
+    <p:spTree>
+      <p:nvGrpSpPr>
+        <p:cNvPr id="1" name=""/>
+        <p:cNvGrpSpPr/>
+        <p:nvPr/>
+      </p:nvGrpSpPr>
+      <p:grpSpPr>
+        <a:xfrm>
+          <a:off x="0" y="0"/>
+          <a:ext cx="0" cy="0"/>
+          <a:chOff x="0" y="0"/>
+          <a:chExt cx="0" cy="0"/>
+        </a:xfrm>
+      </p:grpSpPr>
+      <p:sp>
+        <p:nvSpPr>
+          <p:cNvPr id="2" name="Slide Image Placeholder 1"/>
+          <p:cNvSpPr>
+            <a:spLocks noGrp="1"/>
+          </p:cNvSpPr>
+          <p:nvPr>
+            <p:ph type="sldImg" idx="2"/>
+          </p:nvPr>
+        </p:nvSpPr>
+        <p:spPr/>
+      </p:sp>
+      <p:sp>
+        <p:nvSpPr>
+          <p:cNvPr id="3" name="Notes Placeholder 2"/>
+          <p:cNvSpPr>
+            <a:spLocks noGrp="1"/>
+          </p:cNvSpPr>
+          <p:nvPr>
+            <p:ph type="body" idx="3" sz="quarter"/>
+          </p:nvPr>
+        </p:nvSpPr>
+        <p:spPr/>
+        <p:txBody>
+          <a:bodyPr/>
+          <a:lstStyle/>
+          <a:p>
+            <a:r>
+              <a:t>The contribution in one slide: every existing method occupies a cell except de-novo, per-molecule isoform assembly resolved to paralog COPIES. read-coherence (per-molecule structure) plus PSVs (copy identity) on one spliced family variation graph fills it, with a provable identifiability boundary: copies are recoverable iff they differ at &gt;= K PSV columns spanned by enough reads above the error floor; otherwise they are provably merged.</a:t>
+            </a:r>
+          </a:p>
+        </p:txBody>
+      </p:sp>
+      <p:sp>
+        <p:nvSpPr>
+          <p:cNvPr id="4" name="Slide Number Placeholder 3"/>
+          <p:cNvSpPr>
+            <a:spLocks noGrp="1"/>
+          </p:cNvSpPr>
+          <p:nvPr>
+            <p:ph type="sldNum" idx="5" sz="quarter"/>
+          </p:nvPr>
+        </p:nvSpPr>
+        <p:spPr/>
+      </p:sp>
+    </p:spTree>
+  </p:cSld>
+  <p:clrMapOvr>
+    <a:masterClrMapping/>
+  </p:clrMapOvr>
+</p:notes>
+</file>
+
 <file path=ppt/notesSlides/notesSlide2.xml><?xml version="1.0" encoding="utf-8"?>
 <p:notes xmlns:a="http://schemas.openxmlformats.org/drawingml/2006/main" xmlns:p="http://schemas.openxmlformats.org/presentationml/2006/main" xmlns:r="http://schemas.openxmlformats.org/officeDocument/2006/relationships">
   <p:cSld>
@@ -648,7 +864,7 @@
           <a:lstStyle/>
           <a:p>
             <a:r>
-              <a:t>Clustering needs a distance + threshold and can merge distinct molecules; this is a discrete equivalence on junction chains — parameter-free. Junctions are exact; only the 5'/3' ends are soft, handled by the outer-envelope + fragment-collapse so truncation never mints spurious short isoforms.</a:t>
+              <a:t>Clustering needs a distance + threshold and can merge distinct molecules; this is a discrete equivalence on junction chains (a GROUP BY), parameter-free and deterministic. Fragment folding is sub-path containment, not similarity. Junctions are matched exactly (fuzzy-merge off by default); the only tolerance is a few bp at the ragged 5'/3' ends.</a:t>
             </a:r>
           </a:p>
         </p:txBody>
@@ -718,7 +934,7 @@
           <a:lstStyle/>
           <a:p>
             <a:r>
-              <a:t>Two precision mechanisms, both annotation-free. The realness gate keeps a read-chain isoform only if every junction is canonical, it has no RT-switch repeat signature, and read-depth &gt;= min_cov. Degradation-aware collapse folds 5'/3'/internal fragments into their full-length parent (ISM -&gt; FSM).</a:t>
+              <a:t>Alternative splicing is NOT special-cased. A cassette-exon skip, an alternative 5' donor, an alternative 3' acceptor, or intron retention each change the junction list, so each is automatically a different exact key and a distinct transcript. The splice graph (the same one flow uses) represents the alternatives as branch points; read-coherence reads each molecule's realized path through it.</a:t>
             </a:r>
           </a:p>
         </p:txBody>
@@ -788,7 +1004,7 @@
           <a:lstStyle/>
           <a:p>
             <a:r>
-              <a:t>Read-chain is held out of every per-bundle and global filter that could displace a flow transcript, then unioned back only as NOVEL intron chains and passed through the gate. So the output is a provable superset of the flow baseline: genome-wide gd\rcg = 0 and st\rcg = 0 (never loses a flow find or a StringTie guide).</a:t>
+              <a:t>Two precision mechanisms, both annotation-free. The realness gate keeps a read-chain isoform only if every junction is canonical, it has no RT-switch repeat signature, and read-depth &gt;= min_cov. Degradation-aware collapse folds 5'/3'/internal fragments into their full-length parent (ISM -&gt; FSM).</a:t>
             </a:r>
           </a:p>
         </p:txBody>
@@ -858,7 +1074,217 @@
           <a:lstStyle/>
           <a:p>
             <a:r>
+              <a:t>Read-chain is held out of every per-bundle and global filter that could displace a flow transcript, then unioned back only as NOVEL intron chains and passed through the gate. So the output is a provable superset of the flow baseline: genome-wide gd\rcg = 0 and st\rcg = 0 (never loses a flow find or a StringTie guide).</a:t>
+            </a:r>
+          </a:p>
+        </p:txBody>
+      </p:sp>
+      <p:sp>
+        <p:nvSpPr>
+          <p:cNvPr id="4" name="Slide Number Placeholder 3"/>
+          <p:cNvSpPr>
+            <a:spLocks noGrp="1"/>
+          </p:cNvSpPr>
+          <p:nvPr>
+            <p:ph type="sldNum" idx="5" sz="quarter"/>
+          </p:nvPr>
+        </p:nvSpPr>
+        <p:spPr/>
+      </p:sp>
+    </p:spTree>
+  </p:cSld>
+  <p:clrMapOvr>
+    <a:masterClrMapping/>
+  </p:clrMapOvr>
+</p:notes>
+</file>
+
+<file path=ppt/notesSlides/notesSlide7.xml><?xml version="1.0" encoding="utf-8"?>
+<p:notes xmlns:a="http://schemas.openxmlformats.org/drawingml/2006/main" xmlns:p="http://schemas.openxmlformats.org/presentationml/2006/main" xmlns:r="http://schemas.openxmlformats.org/officeDocument/2006/relationships">
+  <p:cSld>
+    <p:spTree>
+      <p:nvGrpSpPr>
+        <p:cNvPr id="1" name=""/>
+        <p:cNvGrpSpPr/>
+        <p:nvPr/>
+      </p:nvGrpSpPr>
+      <p:grpSpPr>
+        <a:xfrm>
+          <a:off x="0" y="0"/>
+          <a:ext cx="0" cy="0"/>
+          <a:chOff x="0" y="0"/>
+          <a:chExt cx="0" cy="0"/>
+        </a:xfrm>
+      </p:grpSpPr>
+      <p:sp>
+        <p:nvSpPr>
+          <p:cNvPr id="2" name="Slide Image Placeholder 1"/>
+          <p:cNvSpPr>
+            <a:spLocks noGrp="1"/>
+          </p:cNvSpPr>
+          <p:nvPr>
+            <p:ph type="sldImg" idx="2"/>
+          </p:nvPr>
+        </p:nvSpPr>
+        <p:spPr/>
+      </p:sp>
+      <p:sp>
+        <p:nvSpPr>
+          <p:cNvPr id="3" name="Notes Placeholder 2"/>
+          <p:cNvSpPr>
+            <a:spLocks noGrp="1"/>
+          </p:cNvSpPr>
+          <p:nvPr>
+            <p:ph type="body" idx="3" sz="quarter"/>
+          </p:nvPr>
+        </p:nvSpPr>
+        <p:spPr/>
+        <p:txBody>
+          <a:bodyPr/>
+          <a:lstStyle/>
+          <a:p>
+            <a:r>
+              <a:t>This is figure 3 in code. Steps 1-3 are extract_transcripts_readchain: GROUP BY the exact intron chain (a hash key, an equivalence relation - not a distance/threshold), envelope the ragged 5'/3' ends, fold truncated fragments into their containing full-length chain. Step 4 is the additive merge: the flow assembly is the floor; read-chains are held out of the flow filters, then only NOVEL chains that pass the annotation-free realness gate (every junction canonical, no RT-switch, depth &gt;= K) are added - so output is a provable superset of the flow output.</a:t>
+            </a:r>
+          </a:p>
+        </p:txBody>
+      </p:sp>
+      <p:sp>
+        <p:nvSpPr>
+          <p:cNvPr id="4" name="Slide Number Placeholder 3"/>
+          <p:cNvSpPr>
+            <a:spLocks noGrp="1"/>
+          </p:cNvSpPr>
+          <p:nvPr>
+            <p:ph type="sldNum" idx="5" sz="quarter"/>
+          </p:nvPr>
+        </p:nvSpPr>
+        <p:spPr/>
+      </p:sp>
+    </p:spTree>
+  </p:cSld>
+  <p:clrMapOvr>
+    <a:masterClrMapping/>
+  </p:clrMapOvr>
+</p:notes>
+</file>
+
+<file path=ppt/notesSlides/notesSlide8.xml><?xml version="1.0" encoding="utf-8"?>
+<p:notes xmlns:a="http://schemas.openxmlformats.org/drawingml/2006/main" xmlns:p="http://schemas.openxmlformats.org/presentationml/2006/main" xmlns:r="http://schemas.openxmlformats.org/officeDocument/2006/relationships">
+  <p:cSld>
+    <p:spTree>
+      <p:nvGrpSpPr>
+        <p:cNvPr id="1" name=""/>
+        <p:cNvGrpSpPr/>
+        <p:nvPr/>
+      </p:nvGrpSpPr>
+      <p:grpSpPr>
+        <a:xfrm>
+          <a:off x="0" y="0"/>
+          <a:ext cx="0" cy="0"/>
+          <a:chOff x="0" y="0"/>
+          <a:chExt cx="0" cy="0"/>
+        </a:xfrm>
+      </p:grpSpPr>
+      <p:sp>
+        <p:nvSpPr>
+          <p:cNvPr id="2" name="Slide Image Placeholder 1"/>
+          <p:cNvSpPr>
+            <a:spLocks noGrp="1"/>
+          </p:cNvSpPr>
+          <p:nvPr>
+            <p:ph type="sldImg" idx="2"/>
+          </p:nvPr>
+        </p:nvSpPr>
+        <p:spPr/>
+      </p:sp>
+      <p:sp>
+        <p:nvSpPr>
+          <p:cNvPr id="3" name="Notes Placeholder 2"/>
+          <p:cNvSpPr>
+            <a:spLocks noGrp="1"/>
+          </p:cNvSpPr>
+          <p:nvPr>
+            <p:ph type="body" idx="3" sz="quarter"/>
+          </p:nvPr>
+        </p:nvSpPr>
+        <p:spPr/>
+        <p:txBody>
+          <a:bodyPr/>
+          <a:lstStyle/>
+          <a:p>
+            <a:r>
               <a:t>Genome-wide (25 chromosomes). At the shipped default min_cov=3 (the precision/recall knee), read-coherence recovers +1,735 exact (FSM) annotated isoforms StringTie misses — about 3x the raw per-molecule approach. Of the gated read-chain extras: 100% canonical, 63% real, 12% noise.</a:t>
+            </a:r>
+          </a:p>
+        </p:txBody>
+      </p:sp>
+      <p:sp>
+        <p:nvSpPr>
+          <p:cNvPr id="4" name="Slide Number Placeholder 3"/>
+          <p:cNvSpPr>
+            <a:spLocks noGrp="1"/>
+          </p:cNvSpPr>
+          <p:nvPr>
+            <p:ph type="sldNum" idx="5" sz="quarter"/>
+          </p:nvPr>
+        </p:nvSpPr>
+        <p:spPr/>
+      </p:sp>
+    </p:spTree>
+  </p:cSld>
+  <p:clrMapOvr>
+    <a:masterClrMapping/>
+  </p:clrMapOvr>
+</p:notes>
+</file>
+
+<file path=ppt/notesSlides/notesSlide9.xml><?xml version="1.0" encoding="utf-8"?>
+<p:notes xmlns:a="http://schemas.openxmlformats.org/drawingml/2006/main" xmlns:p="http://schemas.openxmlformats.org/presentationml/2006/main" xmlns:r="http://schemas.openxmlformats.org/officeDocument/2006/relationships">
+  <p:cSld>
+    <p:spTree>
+      <p:nvGrpSpPr>
+        <p:cNvPr id="1" name=""/>
+        <p:cNvGrpSpPr/>
+        <p:nvPr/>
+      </p:nvGrpSpPr>
+      <p:grpSpPr>
+        <a:xfrm>
+          <a:off x="0" y="0"/>
+          <a:ext cx="0" cy="0"/>
+          <a:chOff x="0" y="0"/>
+          <a:chExt cx="0" cy="0"/>
+        </a:xfrm>
+      </p:grpSpPr>
+      <p:sp>
+        <p:nvSpPr>
+          <p:cNvPr id="2" name="Slide Image Placeholder 1"/>
+          <p:cNvSpPr>
+            <a:spLocks noGrp="1"/>
+          </p:cNvSpPr>
+          <p:nvPr>
+            <p:ph type="sldImg" idx="2"/>
+          </p:nvPr>
+        </p:nvSpPr>
+        <p:spPr/>
+      </p:sp>
+      <p:sp>
+        <p:nvSpPr>
+          <p:cNvPr id="3" name="Notes Placeholder 2"/>
+          <p:cNvSpPr>
+            <a:spLocks noGrp="1"/>
+          </p:cNvSpPr>
+          <p:nvPr>
+            <p:ph type="body" idx="3" sz="quarter"/>
+          </p:nvPr>
+        </p:nvSpPr>
+        <p:spPr/>
+        <p:txBody>
+          <a:bodyPr/>
+          <a:lstStyle/>
+          <a:p>
+            <a:r>
+              <a:t>Be upfront: grouping reads by intron chain is the standard long-read collapse (Cupcake, IsoSeq, FLAIR, TALON, IsoQuant, Mandalorion), and IsoQuant already showed per-read methods beat StringTie's graph/flow assembly on novel isoforms with lower FP. So the algorithm and the beat-StringTie result are prior art. What is ours: doing it as a provably-additive layer over a StringTie flow port (output superset of flow) in one tool, plus the annotation-free realness gate. The genuine novelty is the next slide — paralog-copy resolution via PSVs on a shared family graph.</a:t>
             </a:r>
           </a:p>
         </p:txBody>
@@ -3896,6 +4322,174 @@
 </p:sld>
 </file>
 
+<file path=ppt/slides/slide10.xml><?xml version="1.0" encoding="utf-8"?>
+<p:sld xmlns:a="http://schemas.openxmlformats.org/drawingml/2006/main" xmlns:p="http://schemas.openxmlformats.org/presentationml/2006/main" xmlns:r="http://schemas.openxmlformats.org/officeDocument/2006/relationships">
+  <p:cSld>
+    <p:spTree>
+      <p:nvGrpSpPr>
+        <p:cNvPr id="1" name=""/>
+        <p:cNvGrpSpPr/>
+        <p:nvPr/>
+      </p:nvGrpSpPr>
+      <p:grpSpPr/>
+      <p:pic>
+        <p:nvPicPr>
+          <p:cNvPr id="2" name="Picture 1" descr="slide10.png"/>
+          <p:cNvPicPr>
+            <a:picLocks noChangeAspect="1"/>
+          </p:cNvPicPr>
+          <p:nvPr/>
+        </p:nvPicPr>
+        <p:blipFill>
+          <a:blip r:embed="rId2"/>
+          <a:stretch>
+            <a:fillRect/>
+          </a:stretch>
+        </p:blipFill>
+        <p:spPr>
+          <a:xfrm>
+            <a:off x="0" y="0"/>
+            <a:ext cx="12191695" cy="6858000"/>
+          </a:xfrm>
+          <a:prstGeom prst="rect">
+            <a:avLst/>
+          </a:prstGeom>
+        </p:spPr>
+      </p:pic>
+    </p:spTree>
+  </p:cSld>
+  <p:clrMapOvr>
+    <a:masterClrMapping/>
+  </p:clrMapOvr>
+</p:sld>
+</file>
+
+<file path=ppt/slides/slide11.xml><?xml version="1.0" encoding="utf-8"?>
+<p:sld xmlns:a="http://schemas.openxmlformats.org/drawingml/2006/main" xmlns:p="http://schemas.openxmlformats.org/presentationml/2006/main" xmlns:r="http://schemas.openxmlformats.org/officeDocument/2006/relationships">
+  <p:cSld>
+    <p:spTree>
+      <p:nvGrpSpPr>
+        <p:cNvPr id="1" name=""/>
+        <p:cNvGrpSpPr/>
+        <p:nvPr/>
+      </p:nvGrpSpPr>
+      <p:grpSpPr/>
+      <p:pic>
+        <p:nvPicPr>
+          <p:cNvPr id="2" name="Picture 1" descr="slide11.png"/>
+          <p:cNvPicPr>
+            <a:picLocks noChangeAspect="1"/>
+          </p:cNvPicPr>
+          <p:nvPr/>
+        </p:nvPicPr>
+        <p:blipFill>
+          <a:blip r:embed="rId2"/>
+          <a:stretch>
+            <a:fillRect/>
+          </a:stretch>
+        </p:blipFill>
+        <p:spPr>
+          <a:xfrm>
+            <a:off x="0" y="0"/>
+            <a:ext cx="12191695" cy="6858000"/>
+          </a:xfrm>
+          <a:prstGeom prst="rect">
+            <a:avLst/>
+          </a:prstGeom>
+        </p:spPr>
+      </p:pic>
+    </p:spTree>
+  </p:cSld>
+  <p:clrMapOvr>
+    <a:masterClrMapping/>
+  </p:clrMapOvr>
+</p:sld>
+</file>
+
+<file path=ppt/slides/slide12.xml><?xml version="1.0" encoding="utf-8"?>
+<p:sld xmlns:a="http://schemas.openxmlformats.org/drawingml/2006/main" xmlns:p="http://schemas.openxmlformats.org/presentationml/2006/main" xmlns:r="http://schemas.openxmlformats.org/officeDocument/2006/relationships">
+  <p:cSld>
+    <p:spTree>
+      <p:nvGrpSpPr>
+        <p:cNvPr id="1" name=""/>
+        <p:cNvGrpSpPr/>
+        <p:nvPr/>
+      </p:nvGrpSpPr>
+      <p:grpSpPr/>
+      <p:pic>
+        <p:nvPicPr>
+          <p:cNvPr id="2" name="Picture 1" descr="slide12.png"/>
+          <p:cNvPicPr>
+            <a:picLocks noChangeAspect="1"/>
+          </p:cNvPicPr>
+          <p:nvPr/>
+        </p:nvPicPr>
+        <p:blipFill>
+          <a:blip r:embed="rId2"/>
+          <a:stretch>
+            <a:fillRect/>
+          </a:stretch>
+        </p:blipFill>
+        <p:spPr>
+          <a:xfrm>
+            <a:off x="0" y="0"/>
+            <a:ext cx="12191695" cy="6858000"/>
+          </a:xfrm>
+          <a:prstGeom prst="rect">
+            <a:avLst/>
+          </a:prstGeom>
+        </p:spPr>
+      </p:pic>
+    </p:spTree>
+  </p:cSld>
+  <p:clrMapOvr>
+    <a:masterClrMapping/>
+  </p:clrMapOvr>
+</p:sld>
+</file>
+
+<file path=ppt/slides/slide13.xml><?xml version="1.0" encoding="utf-8"?>
+<p:sld xmlns:a="http://schemas.openxmlformats.org/drawingml/2006/main" xmlns:p="http://schemas.openxmlformats.org/presentationml/2006/main" xmlns:r="http://schemas.openxmlformats.org/officeDocument/2006/relationships">
+  <p:cSld>
+    <p:spTree>
+      <p:nvGrpSpPr>
+        <p:cNvPr id="1" name=""/>
+        <p:cNvGrpSpPr/>
+        <p:nvPr/>
+      </p:nvGrpSpPr>
+      <p:grpSpPr/>
+      <p:pic>
+        <p:nvPicPr>
+          <p:cNvPr id="2" name="Picture 1" descr="slide13.png"/>
+          <p:cNvPicPr>
+            <a:picLocks noChangeAspect="1"/>
+          </p:cNvPicPr>
+          <p:nvPr/>
+        </p:nvPicPr>
+        <p:blipFill>
+          <a:blip r:embed="rId2"/>
+          <a:stretch>
+            <a:fillRect/>
+          </a:stretch>
+        </p:blipFill>
+        <p:spPr>
+          <a:xfrm>
+            <a:off x="0" y="0"/>
+            <a:ext cx="12191695" cy="6858000"/>
+          </a:xfrm>
+          <a:prstGeom prst="rect">
+            <a:avLst/>
+          </a:prstGeom>
+        </p:spPr>
+      </p:pic>
+    </p:spTree>
+  </p:cSld>
+  <p:clrMapOvr>
+    <a:masterClrMapping/>
+  </p:clrMapOvr>
+</p:sld>
+</file>
+
 <file path=ppt/slides/slide2.xml><?xml version="1.0" encoding="utf-8"?>
 <p:sld xmlns:a="http://schemas.openxmlformats.org/drawingml/2006/main" xmlns:p="http://schemas.openxmlformats.org/presentationml/2006/main" xmlns:r="http://schemas.openxmlformats.org/officeDocument/2006/relationships">
   <p:cSld>
@@ -4119,6 +4713,90 @@
       <p:pic>
         <p:nvPicPr>
           <p:cNvPr id="2" name="Picture 1" descr="slide7.png"/>
+          <p:cNvPicPr>
+            <a:picLocks noChangeAspect="1"/>
+          </p:cNvPicPr>
+          <p:nvPr/>
+        </p:nvPicPr>
+        <p:blipFill>
+          <a:blip r:embed="rId2"/>
+          <a:stretch>
+            <a:fillRect/>
+          </a:stretch>
+        </p:blipFill>
+        <p:spPr>
+          <a:xfrm>
+            <a:off x="0" y="0"/>
+            <a:ext cx="12191695" cy="6858000"/>
+          </a:xfrm>
+          <a:prstGeom prst="rect">
+            <a:avLst/>
+          </a:prstGeom>
+        </p:spPr>
+      </p:pic>
+    </p:spTree>
+  </p:cSld>
+  <p:clrMapOvr>
+    <a:masterClrMapping/>
+  </p:clrMapOvr>
+</p:sld>
+</file>
+
+<file path=ppt/slides/slide8.xml><?xml version="1.0" encoding="utf-8"?>
+<p:sld xmlns:a="http://schemas.openxmlformats.org/drawingml/2006/main" xmlns:p="http://schemas.openxmlformats.org/presentationml/2006/main" xmlns:r="http://schemas.openxmlformats.org/officeDocument/2006/relationships">
+  <p:cSld>
+    <p:spTree>
+      <p:nvGrpSpPr>
+        <p:cNvPr id="1" name=""/>
+        <p:cNvGrpSpPr/>
+        <p:nvPr/>
+      </p:nvGrpSpPr>
+      <p:grpSpPr/>
+      <p:pic>
+        <p:nvPicPr>
+          <p:cNvPr id="2" name="Picture 1" descr="slide8.png"/>
+          <p:cNvPicPr>
+            <a:picLocks noChangeAspect="1"/>
+          </p:cNvPicPr>
+          <p:nvPr/>
+        </p:nvPicPr>
+        <p:blipFill>
+          <a:blip r:embed="rId2"/>
+          <a:stretch>
+            <a:fillRect/>
+          </a:stretch>
+        </p:blipFill>
+        <p:spPr>
+          <a:xfrm>
+            <a:off x="0" y="0"/>
+            <a:ext cx="12191695" cy="6858000"/>
+          </a:xfrm>
+          <a:prstGeom prst="rect">
+            <a:avLst/>
+          </a:prstGeom>
+        </p:spPr>
+      </p:pic>
+    </p:spTree>
+  </p:cSld>
+  <p:clrMapOvr>
+    <a:masterClrMapping/>
+  </p:clrMapOvr>
+</p:sld>
+</file>
+
+<file path=ppt/slides/slide9.xml><?xml version="1.0" encoding="utf-8"?>
+<p:sld xmlns:a="http://schemas.openxmlformats.org/drawingml/2006/main" xmlns:p="http://schemas.openxmlformats.org/presentationml/2006/main" xmlns:r="http://schemas.openxmlformats.org/officeDocument/2006/relationships">
+  <p:cSld>
+    <p:spTree>
+      <p:nvGrpSpPr>
+        <p:cNvPr id="1" name=""/>
+        <p:cNvGrpSpPr/>
+        <p:nvPr/>
+      </p:nvGrpSpPr>
+      <p:grpSpPr/>
+      <p:pic>
+        <p:nvPicPr>
+          <p:cNvPr id="2" name="Picture 1" descr="slide9.png"/>
           <p:cNvPicPr>
             <a:picLocks noChangeAspect="1"/>
           </p:cNvPicPr>

</xml_diff>